<commit_message>
docs: populate student names, roll numbers, roles, certificate, and presentation metadata
</commit_message>
<xml_diff>
--- a/artifacts/presentation/Email_Spam_Detection_Scientific_Presentation.pptx
+++ b/artifacts/presentation/Email_Spam_Detection_Scientific_Presentation.pptx
@@ -4168,14 +4168,14 @@
               <a:spcAft>
                 <a:spcPts val="1200"/>
               </a:spcAft>
-              <a:defRPr sz="1600">
-                <a:solidFill>
-                  <a:srgbClr val="222222"/>
+              <a:defRPr sz="1600" b="1">
+                <a:solidFill>
+                  <a:srgbClr val="003366"/>
                 </a:solidFill>
               </a:defRPr>
             </a:pPr>
             <a:r>
-              <a:t>• Presenter: GANTA BALA AMOGH RAJ</a:t>
+              <a:t>Presenters: GANTA BALA AMOGH RAJ (24VE1A6681) &amp; DOMA AJAY (24VE1A6677)</a:t>
             </a:r>
           </a:p>
           <a:p>

</xml_diff>